<commit_message>
capstone  AI  final submission
</commit_message>
<xml_diff>
--- a/submission/BANANA_Presentation-2.pptx
+++ b/submission/BANANA_Presentation-2.pptx
@@ -13900,8 +13900,8 @@
         </p:nvSpPr>
         <p:spPr>
           <a:xfrm>
-            <a:off x="228600" y="868680"/>
-            <a:ext cx="5669280" cy="2560320"/>
+            <a:off x="238072" y="868680"/>
+            <a:ext cx="5669400" cy="2560200"/>
           </a:xfrm>
           <a:prstGeom prst="rect">
             <a:avLst/>
@@ -14123,7 +14123,7 @@
             <a:r>
               <a:rPr b="0" i="1" lang="en-US" sz="1100" u="none" cap="none" strike="noStrike">
                 <a:solidFill>
-                  <a:srgbClr val="00B4D8"/>
+                  <a:srgbClr val="FFFFFF"/>
                 </a:solidFill>
                 <a:latin typeface="Calibri"/>
                 <a:ea typeface="Calibri"/>
@@ -14134,7 +14134,7 @@
             </a:r>
             <a:endParaRPr b="0" i="0" sz="1100" u="none" cap="none" strike="noStrike">
               <a:solidFill>
-                <a:schemeClr val="dk1"/>
+                <a:srgbClr val="FFFFFF"/>
               </a:solidFill>
               <a:latin typeface="Calibri"/>
               <a:ea typeface="Calibri"/>
@@ -14187,9 +14187,9 @@
               <a:buNone/>
             </a:pPr>
             <a:r>
-              <a:rPr b="0" i="0" lang="en-US" sz="1000" u="none" cap="none" strike="noStrike">
-                <a:solidFill>
-                  <a:srgbClr val="7A9CC4"/>
+              <a:rPr i="1" lang="en-US" sz="1100">
+                <a:solidFill>
+                  <a:srgbClr val="FFFFFF"/>
                 </a:solidFill>
                 <a:latin typeface="Calibri"/>
                 <a:ea typeface="Calibri"/>
@@ -14198,9 +14198,9 @@
               </a:rPr>
               <a:t>Gangadhar Singh Shiva  ·  Akshobhya Rao BV  ·  Ananya Chandraker</a:t>
             </a:r>
-            <a:endParaRPr b="0" i="0" sz="1000" u="none" cap="none" strike="noStrike">
+            <a:endParaRPr i="1" sz="1100">
               <a:solidFill>
-                <a:schemeClr val="dk1"/>
+                <a:srgbClr val="FFFFFF"/>
               </a:solidFill>
               <a:latin typeface="Calibri"/>
               <a:ea typeface="Calibri"/>
@@ -14227,9 +14227,9 @@
               <a:buNone/>
             </a:pPr>
             <a:r>
-              <a:rPr b="0" i="0" lang="en-US" sz="1000" u="none" cap="none" strike="noStrike">
-                <a:solidFill>
-                  <a:srgbClr val="7A9CC4"/>
+              <a:rPr i="1" lang="en-US" sz="1100">
+                <a:solidFill>
+                  <a:srgbClr val="FFFFFF"/>
                 </a:solidFill>
                 <a:latin typeface="Calibri"/>
                 <a:ea typeface="Calibri"/>
@@ -14238,9 +14238,9 @@
               </a:rPr>
               <a:t>MS Applied Artificial Intelligence · University of San Diego</a:t>
             </a:r>
-            <a:endParaRPr b="0" i="0" sz="1000" u="none" cap="none" strike="noStrike">
+            <a:endParaRPr i="1" sz="1100">
               <a:solidFill>
-                <a:schemeClr val="dk1"/>
+                <a:srgbClr val="FFFFFF"/>
               </a:solidFill>
               <a:latin typeface="Calibri"/>
               <a:ea typeface="Calibri"/>
@@ -31284,7 +31284,7 @@
             <a:tbl>
               <a:tblPr>
                 <a:noFill/>
-                <a:tableStyleId>{4A3F0071-CCB1-42BF-92A0-1E05931E6A1B}</a:tableStyleId>
+                <a:tableStyleId>{D4F42CB0-8C47-47A8-97B8-7C13D60FE1B8}</a:tableStyleId>
               </a:tblPr>
               <a:tblGrid>
                 <a:gridCol w="2834650"/>

</xml_diff>